<commit_message>
Fix leasing slide: resolve all text overlaps, tighten stat/price/logo layout
</commit_message>
<xml_diff>
--- a/leasing-slide-main.pptx
+++ b/leasing-slide-main.pptx
@@ -3178,42 +3178,7 @@
       </p:sp>
       <p:sp>
         <p:nvSpPr>
-          <p:cNvPr id="4" name="TextBox 3"/>
-          <p:cNvSpPr txBox="1"/>
-          <p:nvPr/>
-        </p:nvSpPr>
-        <p:spPr>
-          <a:xfrm>
-            <a:off x="3143250" y="4572000"/>
-            <a:ext cx="1905000" cy="571500"/>
-          </a:xfrm>
-          <a:prstGeom prst="rect">
-            <a:avLst/>
-          </a:prstGeom>
-          <a:noFill/>
-        </p:spPr>
-        <p:txBody>
-          <a:bodyPr wrap="square" lIns="50800" tIns="25400" rIns="50800" bIns="25400">
-            <a:spAutoFit/>
-          </a:bodyPr>
-          <a:lstStyle/>
-          <a:p>
-            <a:pPr algn="ctr"/>
-            <a:r>
-              <a:rPr sz="1000" b="1" i="0">
-                <a:solidFill>
-                  <a:srgbClr val="2A3A6E"/>
-                </a:solidFill>
-                <a:latin typeface="Calibri"/>
-              </a:rPr>
-              <a:t>PROPERTY PHOTO</a:t>
-            </a:r>
-          </a:p>
-        </p:txBody>
-      </p:sp>
-      <p:sp>
-        <p:nvSpPr>
-          <p:cNvPr id="5" name="Rectangle 4"/>
+          <p:cNvPr id="4" name="Rectangle 3"/>
           <p:cNvSpPr/>
           <p:nvPr/>
         </p:nvSpPr>
@@ -3256,14 +3221,14 @@
       </p:sp>
       <p:sp>
         <p:nvSpPr>
-          <p:cNvPr id="6" name="TextBox 5"/>
+          <p:cNvPr id="5" name="TextBox 4"/>
           <p:cNvSpPr txBox="1"/>
           <p:nvPr/>
         </p:nvSpPr>
         <p:spPr>
           <a:xfrm>
-            <a:off x="8953500" y="533400"/>
-            <a:ext cx="2857500" cy="342900"/>
+            <a:off x="3143250" y="4667250"/>
+            <a:ext cx="1905000" cy="381000"/>
           </a:xfrm>
           <a:prstGeom prst="rect">
             <a:avLst/>
@@ -3271,12 +3236,46 @@
           <a:noFill/>
         </p:spPr>
         <p:txBody>
-          <a:bodyPr wrap="square" lIns="50800" tIns="25400" rIns="50800" bIns="25400">
+          <a:bodyPr wrap="square" lIns="0" tIns="0" rIns="0" bIns="0">
             <a:spAutoFit/>
           </a:bodyPr>
           <a:lstStyle/>
           <a:p>
-            <a:pPr algn="l"/>
+            <a:pPr algn="ctr"/>
+            <a:r>
+              <a:rPr sz="1000" b="1" i="0">
+                <a:solidFill>
+                  <a:srgbClr val="2A3A6E"/>
+                </a:solidFill>
+                <a:latin typeface="Calibri"/>
+              </a:rPr>
+              <a:t>PROPERTY PHOTO</a:t>
+            </a:r>
+          </a:p>
+        </p:txBody>
+      </p:sp>
+      <p:sp>
+        <p:nvSpPr>
+          <p:cNvPr id="6" name="TextBox 5"/>
+          <p:cNvSpPr txBox="1"/>
+          <p:nvPr/>
+        </p:nvSpPr>
+        <p:spPr>
+          <a:xfrm>
+            <a:off x="8953500" y="514350"/>
+            <a:ext cx="4762500" cy="381000"/>
+          </a:xfrm>
+          <a:prstGeom prst="rect">
+            <a:avLst/>
+          </a:prstGeom>
+          <a:noFill/>
+        </p:spPr>
+        <p:txBody>
+          <a:bodyPr wrap="square" lIns="0" tIns="0" rIns="0" bIns="0">
+            <a:spAutoFit/>
+          </a:bodyPr>
+          <a:lstStyle/>
+          <a:p>
             <a:r>
               <a:rPr sz="1600" b="1" i="0">
                 <a:solidFill>
@@ -3286,32 +3285,6 @@
               </a:rPr>
               <a:t>Levy</a:t>
             </a:r>
-          </a:p>
-        </p:txBody>
-      </p:sp>
-      <p:sp>
-        <p:nvSpPr>
-          <p:cNvPr id="7" name="TextBox 6"/>
-          <p:cNvSpPr txBox="1"/>
-          <p:nvPr/>
-        </p:nvSpPr>
-        <p:spPr>
-          <a:xfrm>
-            <a:off x="9505950" y="533400"/>
-            <a:ext cx="2857500" cy="342900"/>
-          </a:xfrm>
-          <a:prstGeom prst="rect">
-            <a:avLst/>
-          </a:prstGeom>
-          <a:noFill/>
-        </p:spPr>
-        <p:txBody>
-          <a:bodyPr wrap="square" lIns="50800" tIns="25400" rIns="50800" bIns="25400">
-            <a:spAutoFit/>
-          </a:bodyPr>
-          <a:lstStyle/>
-          <a:p>
-            <a:pPr algn="l"/>
             <a:r>
               <a:rPr sz="1600" b="0" i="0">
                 <a:solidFill>
@@ -3326,14 +3299,14 @@
       </p:sp>
       <p:sp>
         <p:nvSpPr>
-          <p:cNvPr id="8" name="TextBox 7"/>
+          <p:cNvPr id="7" name="TextBox 6"/>
           <p:cNvSpPr txBox="1"/>
           <p:nvPr/>
         </p:nvSpPr>
         <p:spPr>
           <a:xfrm>
-            <a:off x="8953500" y="1333500"/>
-            <a:ext cx="3810000" cy="266700"/>
+            <a:off x="8953500" y="1066800"/>
+            <a:ext cx="3810000" cy="247649"/>
           </a:xfrm>
           <a:prstGeom prst="rect">
             <a:avLst/>
@@ -3341,7 +3314,7 @@
           <a:noFill/>
         </p:spPr>
         <p:txBody>
-          <a:bodyPr wrap="square" lIns="50800" tIns="25400" rIns="50800" bIns="25400">
+          <a:bodyPr wrap="square" lIns="0" tIns="0" rIns="0" bIns="0">
             <a:spAutoFit/>
           </a:bodyPr>
           <a:lstStyle/>
@@ -3361,14 +3334,14 @@
       </p:sp>
       <p:sp>
         <p:nvSpPr>
-          <p:cNvPr id="9" name="TextBox 8"/>
+          <p:cNvPr id="8" name="TextBox 7"/>
           <p:cNvSpPr txBox="1"/>
           <p:nvPr/>
         </p:nvSpPr>
         <p:spPr>
           <a:xfrm>
-            <a:off x="8953500" y="1695450"/>
-            <a:ext cx="9372600" cy="2571750"/>
+            <a:off x="8953500" y="1409700"/>
+            <a:ext cx="8953500" cy="2667000"/>
           </a:xfrm>
           <a:prstGeom prst="rect">
             <a:avLst/>
@@ -3376,7 +3349,7 @@
           <a:noFill/>
         </p:spPr>
         <p:txBody>
-          <a:bodyPr wrap="square" lIns="50800" tIns="25400" rIns="50800" bIns="25400">
+          <a:bodyPr wrap="square" lIns="0" tIns="0" rIns="0" bIns="0">
             <a:spAutoFit/>
           </a:bodyPr>
           <a:lstStyle/>
@@ -3398,14 +3371,14 @@
       </p:sp>
       <p:sp>
         <p:nvSpPr>
-          <p:cNvPr id="10" name="TextBox 9"/>
+          <p:cNvPr id="9" name="TextBox 8"/>
           <p:cNvSpPr txBox="1"/>
           <p:nvPr/>
         </p:nvSpPr>
         <p:spPr>
           <a:xfrm>
-            <a:off x="8953500" y="4381500"/>
-            <a:ext cx="9372600" cy="304800"/>
+            <a:off x="8953500" y="4229100"/>
+            <a:ext cx="8953500" cy="285750"/>
           </a:xfrm>
           <a:prstGeom prst="rect">
             <a:avLst/>
@@ -3413,7 +3386,7 @@
           <a:noFill/>
         </p:spPr>
         <p:txBody>
-          <a:bodyPr wrap="square" lIns="50800" tIns="25400" rIns="50800" bIns="25400">
+          <a:bodyPr wrap="square" lIns="0" tIns="0" rIns="0" bIns="0">
             <a:spAutoFit/>
           </a:bodyPr>
           <a:lstStyle/>
@@ -3433,14 +3406,14 @@
       </p:sp>
       <p:sp>
         <p:nvSpPr>
-          <p:cNvPr id="11" name="TextBox 10"/>
+          <p:cNvPr id="10" name="TextBox 9"/>
           <p:cNvSpPr txBox="1"/>
           <p:nvPr/>
         </p:nvSpPr>
         <p:spPr>
           <a:xfrm>
-            <a:off x="8953500" y="4953000"/>
-            <a:ext cx="1905000" cy="476250"/>
+            <a:off x="8953500" y="4762500"/>
+            <a:ext cx="1866899" cy="381000"/>
           </a:xfrm>
           <a:prstGeom prst="rect">
             <a:avLst/>
@@ -3448,14 +3421,14 @@
           <a:noFill/>
         </p:spPr>
         <p:txBody>
-          <a:bodyPr wrap="square" lIns="50800" tIns="25400" rIns="50800" bIns="25400">
+          <a:bodyPr wrap="square" lIns="0" tIns="0" rIns="0" bIns="0">
             <a:spAutoFit/>
           </a:bodyPr>
           <a:lstStyle/>
           <a:p>
             <a:pPr algn="l"/>
             <a:r>
-              <a:rPr sz="3800" b="1" i="0">
+              <a:rPr sz="3600" b="1" i="0">
                 <a:solidFill>
                   <a:srgbClr val="FFFFFF"/>
                 </a:solidFill>
@@ -3468,14 +3441,14 @@
       </p:sp>
       <p:sp>
         <p:nvSpPr>
-          <p:cNvPr id="12" name="TextBox 11"/>
+          <p:cNvPr id="11" name="TextBox 10"/>
           <p:cNvSpPr txBox="1"/>
           <p:nvPr/>
         </p:nvSpPr>
         <p:spPr>
           <a:xfrm>
-            <a:off x="8953500" y="5391150"/>
-            <a:ext cx="1905000" cy="228600"/>
+            <a:off x="8953500" y="5162550"/>
+            <a:ext cx="1866899" cy="209550"/>
           </a:xfrm>
           <a:prstGeom prst="rect">
             <a:avLst/>
@@ -3483,7 +3456,7 @@
           <a:noFill/>
         </p:spPr>
         <p:txBody>
-          <a:bodyPr wrap="square" lIns="50800" tIns="25400" rIns="50800" bIns="25400">
+          <a:bodyPr wrap="square" lIns="0" tIns="0" rIns="0" bIns="0">
             <a:spAutoFit/>
           </a:bodyPr>
           <a:lstStyle/>
@@ -3503,14 +3476,14 @@
       </p:sp>
       <p:sp>
         <p:nvSpPr>
-          <p:cNvPr id="13" name="Rectangle 12"/>
+          <p:cNvPr id="12" name="Rectangle 11"/>
           <p:cNvSpPr/>
           <p:nvPr/>
         </p:nvSpPr>
         <p:spPr>
           <a:xfrm>
-            <a:off x="10953750" y="4991100"/>
-            <a:ext cx="9525" cy="571500"/>
+            <a:off x="10934699" y="4800600"/>
+            <a:ext cx="9525" cy="533400"/>
           </a:xfrm>
           <a:prstGeom prst="rect">
             <a:avLst/>
@@ -3546,14 +3519,14 @@
       </p:sp>
       <p:sp>
         <p:nvSpPr>
-          <p:cNvPr id="14" name="TextBox 13"/>
+          <p:cNvPr id="13" name="TextBox 12"/>
           <p:cNvSpPr txBox="1"/>
           <p:nvPr/>
         </p:nvSpPr>
         <p:spPr>
           <a:xfrm>
-            <a:off x="11125200" y="4953000"/>
-            <a:ext cx="1905000" cy="476250"/>
+            <a:off x="11125199" y="4762500"/>
+            <a:ext cx="1866899" cy="381000"/>
           </a:xfrm>
           <a:prstGeom prst="rect">
             <a:avLst/>
@@ -3561,14 +3534,14 @@
           <a:noFill/>
         </p:spPr>
         <p:txBody>
-          <a:bodyPr wrap="square" lIns="50800" tIns="25400" rIns="50800" bIns="25400">
+          <a:bodyPr wrap="square" lIns="0" tIns="0" rIns="0" bIns="0">
             <a:spAutoFit/>
           </a:bodyPr>
           <a:lstStyle/>
           <a:p>
             <a:pPr algn="l"/>
             <a:r>
-              <a:rPr sz="3800" b="1" i="0">
+              <a:rPr sz="3600" b="1" i="0">
                 <a:solidFill>
                   <a:srgbClr val="FFFFFF"/>
                 </a:solidFill>
@@ -3581,14 +3554,14 @@
       </p:sp>
       <p:sp>
         <p:nvSpPr>
-          <p:cNvPr id="15" name="TextBox 14"/>
+          <p:cNvPr id="14" name="TextBox 13"/>
           <p:cNvSpPr txBox="1"/>
           <p:nvPr/>
         </p:nvSpPr>
         <p:spPr>
           <a:xfrm>
-            <a:off x="11125200" y="5391150"/>
-            <a:ext cx="1905000" cy="228600"/>
+            <a:off x="11125199" y="5162550"/>
+            <a:ext cx="1866899" cy="209550"/>
           </a:xfrm>
           <a:prstGeom prst="rect">
             <a:avLst/>
@@ -3596,7 +3569,7 @@
           <a:noFill/>
         </p:spPr>
         <p:txBody>
-          <a:bodyPr wrap="square" lIns="50800" tIns="25400" rIns="50800" bIns="25400">
+          <a:bodyPr wrap="square" lIns="0" tIns="0" rIns="0" bIns="0">
             <a:spAutoFit/>
           </a:bodyPr>
           <a:lstStyle/>
@@ -3616,14 +3589,14 @@
       </p:sp>
       <p:sp>
         <p:nvSpPr>
-          <p:cNvPr id="16" name="Rectangle 15"/>
+          <p:cNvPr id="15" name="Rectangle 14"/>
           <p:cNvSpPr/>
           <p:nvPr/>
         </p:nvSpPr>
         <p:spPr>
           <a:xfrm>
-            <a:off x="13125450" y="4991100"/>
-            <a:ext cx="9525" cy="571500"/>
+            <a:off x="13106398" y="4800600"/>
+            <a:ext cx="9525" cy="533400"/>
           </a:xfrm>
           <a:prstGeom prst="rect">
             <a:avLst/>
@@ -3659,14 +3632,14 @@
       </p:sp>
       <p:sp>
         <p:nvSpPr>
-          <p:cNvPr id="17" name="TextBox 16"/>
+          <p:cNvPr id="16" name="TextBox 15"/>
           <p:cNvSpPr txBox="1"/>
           <p:nvPr/>
         </p:nvSpPr>
         <p:spPr>
           <a:xfrm>
-            <a:off x="13296900" y="4953000"/>
-            <a:ext cx="1905000" cy="476250"/>
+            <a:off x="13296898" y="4762500"/>
+            <a:ext cx="1866899" cy="381000"/>
           </a:xfrm>
           <a:prstGeom prst="rect">
             <a:avLst/>
@@ -3674,14 +3647,14 @@
           <a:noFill/>
         </p:spPr>
         <p:txBody>
-          <a:bodyPr wrap="square" lIns="50800" tIns="25400" rIns="50800" bIns="25400">
+          <a:bodyPr wrap="square" lIns="0" tIns="0" rIns="0" bIns="0">
             <a:spAutoFit/>
           </a:bodyPr>
           <a:lstStyle/>
           <a:p>
             <a:pPr algn="l"/>
             <a:r>
-              <a:rPr sz="3800" b="1" i="0">
+              <a:rPr sz="3600" b="1" i="0">
                 <a:solidFill>
                   <a:srgbClr val="FFFFFF"/>
                 </a:solidFill>
@@ -3694,14 +3667,14 @@
       </p:sp>
       <p:sp>
         <p:nvSpPr>
-          <p:cNvPr id="18" name="TextBox 17"/>
+          <p:cNvPr id="17" name="TextBox 16"/>
           <p:cNvSpPr txBox="1"/>
           <p:nvPr/>
         </p:nvSpPr>
         <p:spPr>
           <a:xfrm>
-            <a:off x="13296900" y="5391150"/>
-            <a:ext cx="1905000" cy="228600"/>
+            <a:off x="13296898" y="5162550"/>
+            <a:ext cx="1866899" cy="209550"/>
           </a:xfrm>
           <a:prstGeom prst="rect">
             <a:avLst/>
@@ -3709,7 +3682,7 @@
           <a:noFill/>
         </p:spPr>
         <p:txBody>
-          <a:bodyPr wrap="square" lIns="50800" tIns="25400" rIns="50800" bIns="25400">
+          <a:bodyPr wrap="square" lIns="0" tIns="0" rIns="0" bIns="0">
             <a:spAutoFit/>
           </a:bodyPr>
           <a:lstStyle/>
@@ -3729,14 +3702,14 @@
       </p:sp>
       <p:sp>
         <p:nvSpPr>
-          <p:cNvPr id="19" name="Rectangle 18"/>
+          <p:cNvPr id="18" name="Rectangle 17"/>
           <p:cNvSpPr/>
           <p:nvPr/>
         </p:nvSpPr>
         <p:spPr>
           <a:xfrm>
-            <a:off x="15297150" y="4991100"/>
-            <a:ext cx="9525" cy="571500"/>
+            <a:off x="15278097" y="4800600"/>
+            <a:ext cx="9525" cy="533400"/>
           </a:xfrm>
           <a:prstGeom prst="rect">
             <a:avLst/>
@@ -3772,14 +3745,14 @@
       </p:sp>
       <p:sp>
         <p:nvSpPr>
-          <p:cNvPr id="20" name="TextBox 19"/>
+          <p:cNvPr id="19" name="TextBox 18"/>
           <p:cNvSpPr txBox="1"/>
           <p:nvPr/>
         </p:nvSpPr>
         <p:spPr>
           <a:xfrm>
-            <a:off x="15468600" y="4953000"/>
-            <a:ext cx="1905000" cy="476250"/>
+            <a:off x="15468597" y="4762500"/>
+            <a:ext cx="1866899" cy="381000"/>
           </a:xfrm>
           <a:prstGeom prst="rect">
             <a:avLst/>
@@ -3787,14 +3760,14 @@
           <a:noFill/>
         </p:spPr>
         <p:txBody>
-          <a:bodyPr wrap="square" lIns="50800" tIns="25400" rIns="50800" bIns="25400">
+          <a:bodyPr wrap="square" lIns="0" tIns="0" rIns="0" bIns="0">
             <a:spAutoFit/>
           </a:bodyPr>
           <a:lstStyle/>
           <a:p>
             <a:pPr algn="l"/>
             <a:r>
-              <a:rPr sz="3800" b="1" i="0">
+              <a:rPr sz="3600" b="1" i="0">
                 <a:solidFill>
                   <a:srgbClr val="FFFFFF"/>
                 </a:solidFill>
@@ -3807,14 +3780,14 @@
       </p:sp>
       <p:sp>
         <p:nvSpPr>
-          <p:cNvPr id="21" name="TextBox 20"/>
+          <p:cNvPr id="20" name="TextBox 19"/>
           <p:cNvSpPr txBox="1"/>
           <p:nvPr/>
         </p:nvSpPr>
         <p:spPr>
           <a:xfrm>
-            <a:off x="15468600" y="5391150"/>
-            <a:ext cx="1905000" cy="228600"/>
+            <a:off x="15468597" y="5162550"/>
+            <a:ext cx="1866899" cy="209550"/>
           </a:xfrm>
           <a:prstGeom prst="rect">
             <a:avLst/>
@@ -3822,7 +3795,7 @@
           <a:noFill/>
         </p:spPr>
         <p:txBody>
-          <a:bodyPr wrap="square" lIns="50800" tIns="25400" rIns="50800" bIns="25400">
+          <a:bodyPr wrap="square" lIns="0" tIns="0" rIns="0" bIns="0">
             <a:spAutoFit/>
           </a:bodyPr>
           <a:lstStyle/>
@@ -3842,14 +3815,14 @@
       </p:sp>
       <p:sp>
         <p:nvSpPr>
-          <p:cNvPr id="22" name="TextBox 21"/>
+          <p:cNvPr id="21" name="TextBox 20"/>
           <p:cNvSpPr txBox="1"/>
           <p:nvPr/>
         </p:nvSpPr>
         <p:spPr>
           <a:xfrm>
-            <a:off x="8953500" y="6096000"/>
-            <a:ext cx="762000" cy="419100"/>
+            <a:off x="8953500" y="5867400"/>
+            <a:ext cx="209550" cy="285750"/>
           </a:xfrm>
           <a:prstGeom prst="rect">
             <a:avLst/>
@@ -3857,18 +3830,18 @@
           <a:noFill/>
         </p:spPr>
         <p:txBody>
-          <a:bodyPr wrap="square" lIns="50800" tIns="25400" rIns="50800" bIns="25400">
+          <a:bodyPr wrap="square" lIns="0" tIns="0" rIns="0" bIns="0">
             <a:spAutoFit/>
           </a:bodyPr>
           <a:lstStyle/>
           <a:p>
             <a:pPr algn="l"/>
             <a:r>
-              <a:rPr sz="2000" b="0" i="0">
+              <a:rPr sz="1400" b="0" i="0">
                 <a:solidFill>
                   <a:srgbClr val="01FFB7"/>
                 </a:solidFill>
-                <a:latin typeface="Bookman Old Style"/>
+                <a:latin typeface="Calibri"/>
               </a:rPr>
               <a:t>$</a:t>
             </a:r>
@@ -3877,14 +3850,14 @@
       </p:sp>
       <p:sp>
         <p:nvSpPr>
-          <p:cNvPr id="23" name="TextBox 22"/>
+          <p:cNvPr id="22" name="TextBox 21"/>
           <p:cNvSpPr txBox="1"/>
           <p:nvPr/>
         </p:nvSpPr>
         <p:spPr>
           <a:xfrm>
-            <a:off x="9220200" y="6096000"/>
-            <a:ext cx="1905000" cy="533400"/>
+            <a:off x="9182100" y="5810250"/>
+            <a:ext cx="1714500" cy="514350"/>
           </a:xfrm>
           <a:prstGeom prst="rect">
             <a:avLst/>
@@ -3892,7 +3865,7 @@
           <a:noFill/>
         </p:spPr>
         <p:txBody>
-          <a:bodyPr wrap="square" lIns="50800" tIns="25400" rIns="50800" bIns="25400">
+          <a:bodyPr wrap="square" lIns="0" tIns="0" rIns="0" bIns="0">
             <a:spAutoFit/>
           </a:bodyPr>
           <a:lstStyle/>
@@ -3912,14 +3885,14 @@
       </p:sp>
       <p:sp>
         <p:nvSpPr>
-          <p:cNvPr id="24" name="TextBox 23"/>
+          <p:cNvPr id="23" name="TextBox 22"/>
           <p:cNvSpPr txBox="1"/>
           <p:nvPr/>
         </p:nvSpPr>
         <p:spPr>
           <a:xfrm>
-            <a:off x="10810875" y="6191250"/>
-            <a:ext cx="1143000" cy="266700"/>
+            <a:off x="11029950" y="5943600"/>
+            <a:ext cx="1143000" cy="247649"/>
           </a:xfrm>
           <a:prstGeom prst="rect">
             <a:avLst/>
@@ -3927,7 +3900,7 @@
           <a:noFill/>
         </p:spPr>
         <p:txBody>
-          <a:bodyPr wrap="square" lIns="50800" tIns="25400" rIns="50800" bIns="25400">
+          <a:bodyPr wrap="square" lIns="0" tIns="0" rIns="0" bIns="0">
             <a:spAutoFit/>
           </a:bodyPr>
           <a:lstStyle/>
@@ -3947,14 +3920,14 @@
       </p:sp>
       <p:sp>
         <p:nvSpPr>
-          <p:cNvPr id="25" name="Rectangle 24"/>
+          <p:cNvPr id="24" name="Rectangle 23"/>
           <p:cNvSpPr/>
           <p:nvPr/>
         </p:nvSpPr>
         <p:spPr>
           <a:xfrm>
-            <a:off x="12096750" y="6153150"/>
-            <a:ext cx="2667000" cy="361950"/>
+            <a:off x="12344400" y="5886450"/>
+            <a:ext cx="2571750" cy="342900"/>
           </a:xfrm>
           <a:prstGeom prst="rect">
             <a:avLst/>
@@ -3992,14 +3965,14 @@
       </p:sp>
       <p:sp>
         <p:nvSpPr>
-          <p:cNvPr id="26" name="TextBox 25"/>
+          <p:cNvPr id="25" name="TextBox 24"/>
           <p:cNvSpPr txBox="1"/>
           <p:nvPr/>
         </p:nvSpPr>
         <p:spPr>
           <a:xfrm>
-            <a:off x="12287250" y="6219824"/>
-            <a:ext cx="2476500" cy="228600"/>
+            <a:off x="12458700" y="5962650"/>
+            <a:ext cx="2457450" cy="209550"/>
           </a:xfrm>
           <a:prstGeom prst="rect">
             <a:avLst/>
@@ -4007,7 +3980,7 @@
           <a:noFill/>
         </p:spPr>
         <p:txBody>
-          <a:bodyPr wrap="square" lIns="50800" tIns="25400" rIns="50800" bIns="25400">
+          <a:bodyPr wrap="square" lIns="0" tIns="0" rIns="0" bIns="0">
             <a:spAutoFit/>
           </a:bodyPr>
           <a:lstStyle/>
@@ -4027,14 +4000,14 @@
       </p:sp>
       <p:sp>
         <p:nvSpPr>
-          <p:cNvPr id="27" name="Rectangle 26"/>
+          <p:cNvPr id="26" name="Rectangle 25"/>
           <p:cNvSpPr/>
           <p:nvPr/>
         </p:nvSpPr>
         <p:spPr>
           <a:xfrm>
-            <a:off x="8953500" y="6953250"/>
-            <a:ext cx="9372600" cy="9525"/>
+            <a:off x="8953500" y="6648450"/>
+            <a:ext cx="8953500" cy="9525"/>
           </a:xfrm>
           <a:prstGeom prst="rect">
             <a:avLst/>
@@ -4070,14 +4043,14 @@
       </p:sp>
       <p:sp>
         <p:nvSpPr>
-          <p:cNvPr id="28" name="TextBox 27"/>
+          <p:cNvPr id="27" name="TextBox 26"/>
           <p:cNvSpPr txBox="1"/>
           <p:nvPr/>
         </p:nvSpPr>
         <p:spPr>
           <a:xfrm>
-            <a:off x="8953500" y="7105650"/>
-            <a:ext cx="1905000" cy="171450"/>
+            <a:off x="8953500" y="6781800"/>
+            <a:ext cx="2571750" cy="171450"/>
           </a:xfrm>
           <a:prstGeom prst="rect">
             <a:avLst/>
@@ -4085,7 +4058,7 @@
           <a:noFill/>
         </p:spPr>
         <p:txBody>
-          <a:bodyPr wrap="square" lIns="50800" tIns="25400" rIns="50800" bIns="25400">
+          <a:bodyPr wrap="square" lIns="0" tIns="0" rIns="0" bIns="0">
             <a:spAutoFit/>
           </a:bodyPr>
           <a:lstStyle/>
@@ -4105,14 +4078,14 @@
       </p:sp>
       <p:sp>
         <p:nvSpPr>
-          <p:cNvPr id="29" name="TextBox 28"/>
+          <p:cNvPr id="28" name="TextBox 27"/>
           <p:cNvSpPr txBox="1"/>
           <p:nvPr/>
         </p:nvSpPr>
         <p:spPr>
           <a:xfrm>
-            <a:off x="8953500" y="7277100"/>
-            <a:ext cx="2667000" cy="342900"/>
+            <a:off x="8953500" y="6972300"/>
+            <a:ext cx="2571750" cy="323850"/>
           </a:xfrm>
           <a:prstGeom prst="rect">
             <a:avLst/>
@@ -4120,7 +4093,7 @@
           <a:noFill/>
         </p:spPr>
         <p:txBody>
-          <a:bodyPr wrap="square" lIns="50800" tIns="25400" rIns="50800" bIns="25400">
+          <a:bodyPr wrap="square" lIns="0" tIns="0" rIns="0" bIns="0">
             <a:spAutoFit/>
           </a:bodyPr>
           <a:lstStyle/>
@@ -4140,13 +4113,13 @@
       </p:sp>
       <p:sp>
         <p:nvSpPr>
-          <p:cNvPr id="30" name="TextBox 29"/>
+          <p:cNvPr id="29" name="TextBox 28"/>
           <p:cNvSpPr txBox="1"/>
           <p:nvPr/>
         </p:nvSpPr>
         <p:spPr>
           <a:xfrm>
-            <a:off x="11715750" y="7105650"/>
+            <a:off x="11715750" y="6781800"/>
             <a:ext cx="1714500" cy="171450"/>
           </a:xfrm>
           <a:prstGeom prst="rect">
@@ -4155,7 +4128,7 @@
           <a:noFill/>
         </p:spPr>
         <p:txBody>
-          <a:bodyPr wrap="square" lIns="50800" tIns="25400" rIns="50800" bIns="25400">
+          <a:bodyPr wrap="square" lIns="0" tIns="0" rIns="0" bIns="0">
             <a:spAutoFit/>
           </a:bodyPr>
           <a:lstStyle/>
@@ -4175,14 +4148,14 @@
       </p:sp>
       <p:sp>
         <p:nvSpPr>
-          <p:cNvPr id="31" name="TextBox 30"/>
+          <p:cNvPr id="30" name="TextBox 29"/>
           <p:cNvSpPr txBox="1"/>
           <p:nvPr/>
         </p:nvSpPr>
         <p:spPr>
           <a:xfrm>
-            <a:off x="11715750" y="7277100"/>
-            <a:ext cx="1905000" cy="266700"/>
+            <a:off x="11715750" y="6972300"/>
+            <a:ext cx="1809750" cy="266700"/>
           </a:xfrm>
           <a:prstGeom prst="rect">
             <a:avLst/>
@@ -4190,7 +4163,7 @@
           <a:noFill/>
         </p:spPr>
         <p:txBody>
-          <a:bodyPr wrap="square" lIns="50800" tIns="25400" rIns="50800" bIns="25400">
+          <a:bodyPr wrap="square" lIns="0" tIns="0" rIns="0" bIns="0">
             <a:spAutoFit/>
           </a:bodyPr>
           <a:lstStyle/>
@@ -4210,14 +4183,14 @@
       </p:sp>
       <p:sp>
         <p:nvSpPr>
-          <p:cNvPr id="32" name="TextBox 31"/>
+          <p:cNvPr id="31" name="TextBox 30"/>
           <p:cNvSpPr txBox="1"/>
           <p:nvPr/>
         </p:nvSpPr>
         <p:spPr>
           <a:xfrm>
-            <a:off x="13620750" y="7105650"/>
-            <a:ext cx="2476500" cy="171450"/>
+            <a:off x="13639800" y="6781800"/>
+            <a:ext cx="3429000" cy="171450"/>
           </a:xfrm>
           <a:prstGeom prst="rect">
             <a:avLst/>
@@ -4225,7 +4198,7 @@
           <a:noFill/>
         </p:spPr>
         <p:txBody>
-          <a:bodyPr wrap="square" lIns="50800" tIns="25400" rIns="50800" bIns="25400">
+          <a:bodyPr wrap="square" lIns="0" tIns="0" rIns="0" bIns="0">
             <a:spAutoFit/>
           </a:bodyPr>
           <a:lstStyle/>
@@ -4245,14 +4218,14 @@
       </p:sp>
       <p:sp>
         <p:nvSpPr>
-          <p:cNvPr id="33" name="TextBox 32"/>
+          <p:cNvPr id="32" name="TextBox 31"/>
           <p:cNvSpPr txBox="1"/>
           <p:nvPr/>
         </p:nvSpPr>
         <p:spPr>
           <a:xfrm>
-            <a:off x="13620750" y="7277100"/>
-            <a:ext cx="3429000" cy="266700"/>
+            <a:off x="13639800" y="6972300"/>
+            <a:ext cx="3619500" cy="266700"/>
           </a:xfrm>
           <a:prstGeom prst="rect">
             <a:avLst/>
@@ -4260,7 +4233,7 @@
           <a:noFill/>
         </p:spPr>
         <p:txBody>
-          <a:bodyPr wrap="square" lIns="50800" tIns="25400" rIns="50800" bIns="25400">
+          <a:bodyPr wrap="square" lIns="0" tIns="0" rIns="0" bIns="0">
             <a:spAutoFit/>
           </a:bodyPr>
           <a:lstStyle/>
@@ -4280,14 +4253,14 @@
       </p:sp>
       <p:sp>
         <p:nvSpPr>
-          <p:cNvPr id="34" name="TextBox 33"/>
+          <p:cNvPr id="33" name="TextBox 32"/>
           <p:cNvSpPr txBox="1"/>
           <p:nvPr/>
         </p:nvSpPr>
         <p:spPr>
           <a:xfrm>
-            <a:off x="8953500" y="9829800"/>
-            <a:ext cx="9372600" cy="304800"/>
+            <a:off x="8953500" y="9944100"/>
+            <a:ext cx="8953500" cy="266700"/>
           </a:xfrm>
           <a:prstGeom prst="rect">
             <a:avLst/>
@@ -4295,7 +4268,7 @@
           <a:noFill/>
         </p:spPr>
         <p:txBody>
-          <a:bodyPr wrap="square" lIns="50800" tIns="25400" rIns="50800" bIns="25400">
+          <a:bodyPr wrap="square" lIns="0" tIns="0" rIns="0" bIns="0">
             <a:spAutoFit/>
           </a:bodyPr>
           <a:lstStyle/>

</xml_diff>

<commit_message>
Replace leasing flyer + slide with WCAG-compliant 14 Harbor Court versions
</commit_message>
<xml_diff>
--- a/leasing-slide-main.pptx
+++ b/leasing-slide-main.pptx
@@ -3103,7 +3103,7 @@
             <a:avLst/>
           </a:prstGeom>
           <a:solidFill>
-            <a:srgbClr val="01133D"/>
+            <a:srgbClr val="F9F7F3"/>
           </a:solidFill>
           <a:ln>
             <a:noFill/>
@@ -3140,7 +3140,7 @@
         <p:spPr>
           <a:xfrm>
             <a:off x="0" y="0"/>
-            <a:ext cx="8191500" cy="10287000"/>
+            <a:ext cx="6477000" cy="10287000"/>
           </a:xfrm>
           <a:prstGeom prst="rect">
             <a:avLst/>
@@ -3148,10 +3148,8 @@
           <a:solidFill>
             <a:srgbClr val="091A4A"/>
           </a:solidFill>
-          <a:ln w="6350">
-            <a:solidFill>
-              <a:srgbClr val="1A2E6E"/>
-            </a:solidFill>
+          <a:ln>
+            <a:noFill/>
           </a:ln>
         </p:spPr>
         <p:style>
@@ -3178,14 +3176,49 @@
       </p:sp>
       <p:sp>
         <p:nvSpPr>
-          <p:cNvPr id="4" name="Rectangle 3"/>
+          <p:cNvPr id="4" name="TextBox 3"/>
+          <p:cNvSpPr txBox="1"/>
+          <p:nvPr/>
+        </p:nvSpPr>
+        <p:spPr>
+          <a:xfrm>
+            <a:off x="2286000" y="4667250"/>
+            <a:ext cx="1905000" cy="247650"/>
+          </a:xfrm>
+          <a:prstGeom prst="rect">
+            <a:avLst/>
+          </a:prstGeom>
+          <a:noFill/>
+        </p:spPr>
+        <p:txBody>
+          <a:bodyPr wrap="none">
+            <a:spAutoFit/>
+          </a:bodyPr>
+          <a:lstStyle/>
+          <a:p>
+            <a:pPr algn="ctr"/>
+            <a:r>
+              <a:rPr sz="800" b="1">
+                <a:solidFill>
+                  <a:srgbClr val="FFFFFF"/>
+                </a:solidFill>
+                <a:latin typeface="Arial"/>
+              </a:rPr>
+              <a:t>PROPERTY PHOTO</a:t>
+            </a:r>
+          </a:p>
+        </p:txBody>
+      </p:sp>
+      <p:sp>
+        <p:nvSpPr>
+          <p:cNvPr id="5" name="Rectangle 4"/>
           <p:cNvSpPr/>
           <p:nvPr/>
         </p:nvSpPr>
         <p:spPr>
           <a:xfrm>
-            <a:off x="7429500" y="0"/>
-            <a:ext cx="1143000" cy="10287000"/>
+            <a:off x="6477000" y="0"/>
+            <a:ext cx="11811000" cy="1028700"/>
           </a:xfrm>
           <a:prstGeom prst="rect">
             <a:avLst/>
@@ -3221,14 +3254,14 @@
       </p:sp>
       <p:sp>
         <p:nvSpPr>
-          <p:cNvPr id="5" name="TextBox 4"/>
+          <p:cNvPr id="6" name="TextBox 5"/>
           <p:cNvSpPr txBox="1"/>
           <p:nvPr/>
         </p:nvSpPr>
         <p:spPr>
           <a:xfrm>
-            <a:off x="3143250" y="4667250"/>
-            <a:ext cx="1905000" cy="381000"/>
+            <a:off x="6934200" y="266700"/>
+            <a:ext cx="4762500" cy="419100"/>
           </a:xfrm>
           <a:prstGeom prst="rect">
             <a:avLst/>
@@ -3236,34 +3269,43 @@
           <a:noFill/>
         </p:spPr>
         <p:txBody>
-          <a:bodyPr wrap="square" lIns="0" tIns="0" rIns="0" bIns="0">
+          <a:bodyPr wrap="square">
             <a:spAutoFit/>
           </a:bodyPr>
           <a:lstStyle/>
           <a:p>
-            <a:pPr algn="ctr"/>
-            <a:r>
-              <a:rPr sz="1000" b="1" i="0">
-                <a:solidFill>
-                  <a:srgbClr val="2A3A6E"/>
-                </a:solidFill>
-                <a:latin typeface="Calibri"/>
+            <a:pPr algn="l"/>
+            <a:r>
+              <a:rPr sz="1800" b="1">
+                <a:solidFill>
+                  <a:srgbClr val="01FFB7"/>
+                </a:solidFill>
+                <a:latin typeface="Bookman Old Style"/>
               </a:rPr>
-              <a:t>PROPERTY PHOTO</a:t>
-            </a:r>
-          </a:p>
-        </p:txBody>
-      </p:sp>
-      <p:sp>
-        <p:nvSpPr>
-          <p:cNvPr id="6" name="TextBox 5"/>
+              <a:t>Levy</a:t>
+            </a:r>
+            <a:r>
+              <a:rPr sz="1800" b="0">
+                <a:solidFill>
+                  <a:srgbClr val="FFFFFF"/>
+                </a:solidFill>
+                <a:latin typeface="Bookman Old Style"/>
+              </a:rPr>
+              <a:t> Legacy Group.</a:t>
+            </a:r>
+          </a:p>
+        </p:txBody>
+      </p:sp>
+      <p:sp>
+        <p:nvSpPr>
+          <p:cNvPr id="7" name="TextBox 6"/>
           <p:cNvSpPr txBox="1"/>
           <p:nvPr/>
         </p:nvSpPr>
         <p:spPr>
           <a:xfrm>
-            <a:off x="8953500" y="514350"/>
-            <a:ext cx="4762500" cy="381000"/>
+            <a:off x="6934200" y="723900"/>
+            <a:ext cx="2857500" cy="209550"/>
           </a:xfrm>
           <a:prstGeom prst="rect">
             <a:avLst/>
@@ -3271,42 +3313,34 @@
           <a:noFill/>
         </p:spPr>
         <p:txBody>
-          <a:bodyPr wrap="square" lIns="0" tIns="0" rIns="0" bIns="0">
+          <a:bodyPr wrap="none">
             <a:spAutoFit/>
           </a:bodyPr>
           <a:lstStyle/>
           <a:p>
-            <a:r>
-              <a:rPr sz="1600" b="1" i="0">
+            <a:pPr algn="l"/>
+            <a:r>
+              <a:rPr sz="800" b="1">
                 <a:solidFill>
                   <a:srgbClr val="01FFB7"/>
                 </a:solidFill>
-                <a:latin typeface="Bookman Old Style"/>
+                <a:latin typeface="Arial"/>
               </a:rPr>
-              <a:t>Levy</a:t>
-            </a:r>
-            <a:r>
-              <a:rPr sz="1600" b="0" i="0">
-                <a:solidFill>
-                  <a:srgbClr val="FFFFFF"/>
-                </a:solidFill>
-                <a:latin typeface="Bookman Old Style"/>
-              </a:rPr>
-              <a:t> Legacy Group.</a:t>
-            </a:r>
-          </a:p>
-        </p:txBody>
-      </p:sp>
-      <p:sp>
-        <p:nvSpPr>
-          <p:cNvPr id="7" name="TextBox 6"/>
+              <a:t>NOW LEASING</a:t>
+            </a:r>
+          </a:p>
+        </p:txBody>
+      </p:sp>
+      <p:sp>
+        <p:nvSpPr>
+          <p:cNvPr id="8" name="TextBox 7"/>
           <p:cNvSpPr txBox="1"/>
           <p:nvPr/>
         </p:nvSpPr>
         <p:spPr>
           <a:xfrm>
-            <a:off x="8953500" y="1066800"/>
-            <a:ext cx="3810000" cy="247649"/>
+            <a:off x="6934200" y="1409700"/>
+            <a:ext cx="8191500" cy="666750"/>
           </a:xfrm>
           <a:prstGeom prst="rect">
             <a:avLst/>
@@ -3314,34 +3348,34 @@
           <a:noFill/>
         </p:spPr>
         <p:txBody>
-          <a:bodyPr wrap="square" lIns="0" tIns="0" rIns="0" bIns="0">
+          <a:bodyPr wrap="none">
             <a:spAutoFit/>
           </a:bodyPr>
           <a:lstStyle/>
           <a:p>
             <a:pPr algn="l"/>
             <a:r>
-              <a:rPr sz="1100" b="1" i="0">
-                <a:solidFill>
-                  <a:srgbClr val="01FFB7"/>
-                </a:solidFill>
-                <a:latin typeface="Calibri"/>
+              <a:rPr sz="5200" b="1">
+                <a:solidFill>
+                  <a:srgbClr val="01133D"/>
+                </a:solidFill>
+                <a:latin typeface="Bookman Old Style"/>
               </a:rPr>
-              <a:t>NOW LEASING</a:t>
-            </a:r>
-          </a:p>
-        </p:txBody>
-      </p:sp>
-      <p:sp>
-        <p:nvSpPr>
-          <p:cNvPr id="8" name="TextBox 7"/>
+              <a:t>14 Harbor</a:t>
+            </a:r>
+          </a:p>
+        </p:txBody>
+      </p:sp>
+      <p:sp>
+        <p:nvSpPr>
+          <p:cNvPr id="9" name="TextBox 8"/>
           <p:cNvSpPr txBox="1"/>
           <p:nvPr/>
         </p:nvSpPr>
         <p:spPr>
           <a:xfrm>
-            <a:off x="8953500" y="1409700"/>
-            <a:ext cx="8953500" cy="2667000"/>
+            <a:off x="6934200" y="2095500"/>
+            <a:ext cx="8191500" cy="666750"/>
           </a:xfrm>
           <a:prstGeom prst="rect">
             <a:avLst/>
@@ -3349,36 +3383,34 @@
           <a:noFill/>
         </p:spPr>
         <p:txBody>
-          <a:bodyPr wrap="square" lIns="0" tIns="0" rIns="0" bIns="0">
+          <a:bodyPr wrap="none">
             <a:spAutoFit/>
           </a:bodyPr>
           <a:lstStyle/>
           <a:p>
             <a:pPr algn="l"/>
             <a:r>
-              <a:rPr sz="7200" b="1" i="0">
-                <a:solidFill>
-                  <a:srgbClr val="FFFFFF"/>
+              <a:rPr sz="5200" b="1">
+                <a:solidFill>
+                  <a:srgbClr val="01133D"/>
                 </a:solidFill>
                 <a:latin typeface="Bookman Old Style"/>
               </a:rPr>
-              <a:t>123
-Main
-Street</a:t>
-            </a:r>
-          </a:p>
-        </p:txBody>
-      </p:sp>
-      <p:sp>
-        <p:nvSpPr>
-          <p:cNvPr id="9" name="TextBox 8"/>
+              <a:t>Court</a:t>
+            </a:r>
+          </a:p>
+        </p:txBody>
+      </p:sp>
+      <p:sp>
+        <p:nvSpPr>
+          <p:cNvPr id="10" name="TextBox 9"/>
           <p:cNvSpPr txBox="1"/>
           <p:nvPr/>
         </p:nvSpPr>
         <p:spPr>
           <a:xfrm>
-            <a:off x="8953500" y="4229100"/>
-            <a:ext cx="8953500" cy="285750"/>
+            <a:off x="6934200" y="2819400"/>
+            <a:ext cx="6667500" cy="247650"/>
           </a:xfrm>
           <a:prstGeom prst="rect">
             <a:avLst/>
@@ -3386,34 +3418,34 @@
           <a:noFill/>
         </p:spPr>
         <p:txBody>
-          <a:bodyPr wrap="square" lIns="0" tIns="0" rIns="0" bIns="0">
+          <a:bodyPr wrap="none">
             <a:spAutoFit/>
           </a:bodyPr>
           <a:lstStyle/>
           <a:p>
             <a:pPr algn="l"/>
             <a:r>
-              <a:rPr sz="1300" b="0" i="0">
-                <a:solidFill>
-                  <a:srgbClr val="97B9FF"/>
-                </a:solidFill>
-                <a:latin typeface="Calibri"/>
+              <a:rPr sz="1100" b="1">
+                <a:solidFill>
+                  <a:srgbClr val="4C4DC3"/>
+                </a:solidFill>
+                <a:latin typeface="Arial"/>
               </a:rPr>
-              <a:t>Brooklyn, New York  ·  11201</a:t>
-            </a:r>
-          </a:p>
-        </p:txBody>
-      </p:sp>
-      <p:sp>
-        <p:nvSpPr>
-          <p:cNvPr id="10" name="TextBox 9"/>
+              <a:t>JERSEY CITY, NJ  ·  07302</a:t>
+            </a:r>
+          </a:p>
+        </p:txBody>
+      </p:sp>
+      <p:sp>
+        <p:nvSpPr>
+          <p:cNvPr id="11" name="TextBox 10"/>
           <p:cNvSpPr txBox="1"/>
           <p:nvPr/>
         </p:nvSpPr>
         <p:spPr>
           <a:xfrm>
-            <a:off x="8953500" y="4762500"/>
-            <a:ext cx="1866899" cy="381000"/>
+            <a:off x="6934200" y="3238500"/>
+            <a:ext cx="1504950" cy="457200"/>
           </a:xfrm>
           <a:prstGeom prst="rect">
             <a:avLst/>
@@ -3421,34 +3453,34 @@
           <a:noFill/>
         </p:spPr>
         <p:txBody>
-          <a:bodyPr wrap="square" lIns="0" tIns="0" rIns="0" bIns="0">
+          <a:bodyPr wrap="none">
             <a:spAutoFit/>
           </a:bodyPr>
           <a:lstStyle/>
           <a:p>
             <a:pPr algn="l"/>
             <a:r>
-              <a:rPr sz="3600" b="1" i="0">
-                <a:solidFill>
-                  <a:srgbClr val="FFFFFF"/>
+              <a:rPr sz="3600" b="1">
+                <a:solidFill>
+                  <a:srgbClr val="01133D"/>
                 </a:solidFill>
                 <a:latin typeface="Bookman Old Style"/>
               </a:rPr>
-              <a:t>4</a:t>
-            </a:r>
-          </a:p>
-        </p:txBody>
-      </p:sp>
-      <p:sp>
-        <p:nvSpPr>
-          <p:cNvPr id="11" name="TextBox 10"/>
+              <a:t>3</a:t>
+            </a:r>
+          </a:p>
+        </p:txBody>
+      </p:sp>
+      <p:sp>
+        <p:nvSpPr>
+          <p:cNvPr id="12" name="TextBox 11"/>
           <p:cNvSpPr txBox="1"/>
           <p:nvPr/>
         </p:nvSpPr>
         <p:spPr>
           <a:xfrm>
-            <a:off x="8953500" y="5162550"/>
-            <a:ext cx="1866899" cy="209550"/>
+            <a:off x="6934200" y="3714750"/>
+            <a:ext cx="1504950" cy="190500"/>
           </a:xfrm>
           <a:prstGeom prst="rect">
             <a:avLst/>
@@ -3456,18 +3488,18 @@
           <a:noFill/>
         </p:spPr>
         <p:txBody>
-          <a:bodyPr wrap="square" lIns="0" tIns="0" rIns="0" bIns="0">
+          <a:bodyPr wrap="none">
             <a:spAutoFit/>
           </a:bodyPr>
           <a:lstStyle/>
           <a:p>
             <a:pPr algn="l"/>
             <a:r>
-              <a:rPr sz="900" b="1" i="0">
-                <a:solidFill>
-                  <a:srgbClr val="97B9FF"/>
-                </a:solidFill>
-                <a:latin typeface="Calibri"/>
+              <a:rPr sz="800" b="1">
+                <a:solidFill>
+                  <a:srgbClr val="4C4DC3"/>
+                </a:solidFill>
+                <a:latin typeface="Arial"/>
               </a:rPr>
               <a:t>BEDROOMS</a:t>
             </a:r>
@@ -3476,20 +3508,230 @@
       </p:sp>
       <p:sp>
         <p:nvSpPr>
-          <p:cNvPr id="12" name="Rectangle 11"/>
+          <p:cNvPr id="13" name="TextBox 12"/>
+          <p:cNvSpPr txBox="1"/>
+          <p:nvPr/>
+        </p:nvSpPr>
+        <p:spPr>
+          <a:xfrm>
+            <a:off x="8515350" y="3238500"/>
+            <a:ext cx="1504950" cy="457200"/>
+          </a:xfrm>
+          <a:prstGeom prst="rect">
+            <a:avLst/>
+          </a:prstGeom>
+          <a:noFill/>
+        </p:spPr>
+        <p:txBody>
+          <a:bodyPr wrap="none">
+            <a:spAutoFit/>
+          </a:bodyPr>
+          <a:lstStyle/>
+          <a:p>
+            <a:pPr algn="l"/>
+            <a:r>
+              <a:rPr sz="3600" b="1">
+                <a:solidFill>
+                  <a:srgbClr val="01133D"/>
+                </a:solidFill>
+                <a:latin typeface="Bookman Old Style"/>
+              </a:rPr>
+              <a:t>2</a:t>
+            </a:r>
+          </a:p>
+        </p:txBody>
+      </p:sp>
+      <p:sp>
+        <p:nvSpPr>
+          <p:cNvPr id="14" name="TextBox 13"/>
+          <p:cNvSpPr txBox="1"/>
+          <p:nvPr/>
+        </p:nvSpPr>
+        <p:spPr>
+          <a:xfrm>
+            <a:off x="8515350" y="3714750"/>
+            <a:ext cx="1504950" cy="190500"/>
+          </a:xfrm>
+          <a:prstGeom prst="rect">
+            <a:avLst/>
+          </a:prstGeom>
+          <a:noFill/>
+        </p:spPr>
+        <p:txBody>
+          <a:bodyPr wrap="none">
+            <a:spAutoFit/>
+          </a:bodyPr>
+          <a:lstStyle/>
+          <a:p>
+            <a:pPr algn="l"/>
+            <a:r>
+              <a:rPr sz="800" b="1">
+                <a:solidFill>
+                  <a:srgbClr val="4C4DC3"/>
+                </a:solidFill>
+                <a:latin typeface="Arial"/>
+              </a:rPr>
+              <a:t>BATHROOMS</a:t>
+            </a:r>
+          </a:p>
+        </p:txBody>
+      </p:sp>
+      <p:sp>
+        <p:nvSpPr>
+          <p:cNvPr id="15" name="TextBox 14"/>
+          <p:cNvSpPr txBox="1"/>
+          <p:nvPr/>
+        </p:nvSpPr>
+        <p:spPr>
+          <a:xfrm>
+            <a:off x="10096500" y="3238500"/>
+            <a:ext cx="1504950" cy="457200"/>
+          </a:xfrm>
+          <a:prstGeom prst="rect">
+            <a:avLst/>
+          </a:prstGeom>
+          <a:noFill/>
+        </p:spPr>
+        <p:txBody>
+          <a:bodyPr wrap="none">
+            <a:spAutoFit/>
+          </a:bodyPr>
+          <a:lstStyle/>
+          <a:p>
+            <a:pPr algn="l"/>
+            <a:r>
+              <a:rPr sz="3600" b="1">
+                <a:solidFill>
+                  <a:srgbClr val="01133D"/>
+                </a:solidFill>
+                <a:latin typeface="Bookman Old Style"/>
+              </a:rPr>
+              <a:t>1,450</a:t>
+            </a:r>
+          </a:p>
+        </p:txBody>
+      </p:sp>
+      <p:sp>
+        <p:nvSpPr>
+          <p:cNvPr id="16" name="TextBox 15"/>
+          <p:cNvSpPr txBox="1"/>
+          <p:nvPr/>
+        </p:nvSpPr>
+        <p:spPr>
+          <a:xfrm>
+            <a:off x="10096500" y="3714750"/>
+            <a:ext cx="1504950" cy="190500"/>
+          </a:xfrm>
+          <a:prstGeom prst="rect">
+            <a:avLst/>
+          </a:prstGeom>
+          <a:noFill/>
+        </p:spPr>
+        <p:txBody>
+          <a:bodyPr wrap="none">
+            <a:spAutoFit/>
+          </a:bodyPr>
+          <a:lstStyle/>
+          <a:p>
+            <a:pPr algn="l"/>
+            <a:r>
+              <a:rPr sz="800" b="1">
+                <a:solidFill>
+                  <a:srgbClr val="4C4DC3"/>
+                </a:solidFill>
+                <a:latin typeface="Arial"/>
+              </a:rPr>
+              <a:t>SQ FT</a:t>
+            </a:r>
+          </a:p>
+        </p:txBody>
+      </p:sp>
+      <p:sp>
+        <p:nvSpPr>
+          <p:cNvPr id="17" name="TextBox 16"/>
+          <p:cNvSpPr txBox="1"/>
+          <p:nvPr/>
+        </p:nvSpPr>
+        <p:spPr>
+          <a:xfrm>
+            <a:off x="11677650" y="3238500"/>
+            <a:ext cx="1504950" cy="457200"/>
+          </a:xfrm>
+          <a:prstGeom prst="rect">
+            <a:avLst/>
+          </a:prstGeom>
+          <a:noFill/>
+        </p:spPr>
+        <p:txBody>
+          <a:bodyPr wrap="none">
+            <a:spAutoFit/>
+          </a:bodyPr>
+          <a:lstStyle/>
+          <a:p>
+            <a:pPr algn="l"/>
+            <a:r>
+              <a:rPr sz="3600" b="1">
+                <a:solidFill>
+                  <a:srgbClr val="01133D"/>
+                </a:solidFill>
+                <a:latin typeface="Bookman Old Style"/>
+              </a:rPr>
+              <a:t>1987</a:t>
+            </a:r>
+          </a:p>
+        </p:txBody>
+      </p:sp>
+      <p:sp>
+        <p:nvSpPr>
+          <p:cNvPr id="18" name="TextBox 17"/>
+          <p:cNvSpPr txBox="1"/>
+          <p:nvPr/>
+        </p:nvSpPr>
+        <p:spPr>
+          <a:xfrm>
+            <a:off x="11677650" y="3714750"/>
+            <a:ext cx="1504950" cy="190500"/>
+          </a:xfrm>
+          <a:prstGeom prst="rect">
+            <a:avLst/>
+          </a:prstGeom>
+          <a:noFill/>
+        </p:spPr>
+        <p:txBody>
+          <a:bodyPr wrap="none">
+            <a:spAutoFit/>
+          </a:bodyPr>
+          <a:lstStyle/>
+          <a:p>
+            <a:pPr algn="l"/>
+            <a:r>
+              <a:rPr sz="800" b="1">
+                <a:solidFill>
+                  <a:srgbClr val="4C4DC3"/>
+                </a:solidFill>
+                <a:latin typeface="Arial"/>
+              </a:rPr>
+              <a:t>BUILT</a:t>
+            </a:r>
+          </a:p>
+        </p:txBody>
+      </p:sp>
+      <p:sp>
+        <p:nvSpPr>
+          <p:cNvPr id="19" name="Rectangle 18"/>
           <p:cNvSpPr/>
           <p:nvPr/>
         </p:nvSpPr>
         <p:spPr>
           <a:xfrm>
-            <a:off x="10934699" y="4800600"/>
-            <a:ext cx="9525" cy="533400"/>
+            <a:off x="6934200" y="4000500"/>
+            <a:ext cx="8001000" cy="9525"/>
           </a:xfrm>
           <a:prstGeom prst="rect">
             <a:avLst/>
           </a:prstGeom>
           <a:solidFill>
-            <a:srgbClr val="1A2E6E"/>
+            <a:srgbClr val="4C4DC3"/>
           </a:solidFill>
           <a:ln>
             <a:noFill/>
@@ -3519,90 +3761,20 @@
       </p:sp>
       <p:sp>
         <p:nvSpPr>
-          <p:cNvPr id="13" name="TextBox 12"/>
-          <p:cNvSpPr txBox="1"/>
-          <p:nvPr/>
-        </p:nvSpPr>
-        <p:spPr>
-          <a:xfrm>
-            <a:off x="11125199" y="4762500"/>
-            <a:ext cx="1866899" cy="381000"/>
-          </a:xfrm>
-          <a:prstGeom prst="rect">
-            <a:avLst/>
-          </a:prstGeom>
-          <a:noFill/>
-        </p:spPr>
-        <p:txBody>
-          <a:bodyPr wrap="square" lIns="0" tIns="0" rIns="0" bIns="0">
-            <a:spAutoFit/>
-          </a:bodyPr>
-          <a:lstStyle/>
-          <a:p>
-            <a:pPr algn="l"/>
-            <a:r>
-              <a:rPr sz="3600" b="1" i="0">
-                <a:solidFill>
-                  <a:srgbClr val="FFFFFF"/>
-                </a:solidFill>
-                <a:latin typeface="Bookman Old Style"/>
-              </a:rPr>
-              <a:t>2.5</a:t>
-            </a:r>
-          </a:p>
-        </p:txBody>
-      </p:sp>
-      <p:sp>
-        <p:nvSpPr>
-          <p:cNvPr id="14" name="TextBox 13"/>
-          <p:cNvSpPr txBox="1"/>
-          <p:nvPr/>
-        </p:nvSpPr>
-        <p:spPr>
-          <a:xfrm>
-            <a:off x="11125199" y="5162550"/>
-            <a:ext cx="1866899" cy="209550"/>
-          </a:xfrm>
-          <a:prstGeom prst="rect">
-            <a:avLst/>
-          </a:prstGeom>
-          <a:noFill/>
-        </p:spPr>
-        <p:txBody>
-          <a:bodyPr wrap="square" lIns="0" tIns="0" rIns="0" bIns="0">
-            <a:spAutoFit/>
-          </a:bodyPr>
-          <a:lstStyle/>
-          <a:p>
-            <a:pPr algn="l"/>
-            <a:r>
-              <a:rPr sz="900" b="1" i="0">
-                <a:solidFill>
-                  <a:srgbClr val="97B9FF"/>
-                </a:solidFill>
-                <a:latin typeface="Calibri"/>
-              </a:rPr>
-              <a:t>BATHROOMS</a:t>
-            </a:r>
-          </a:p>
-        </p:txBody>
-      </p:sp>
-      <p:sp>
-        <p:nvSpPr>
-          <p:cNvPr id="15" name="Rectangle 14"/>
+          <p:cNvPr id="20" name="Rectangle 19"/>
           <p:cNvSpPr/>
           <p:nvPr/>
         </p:nvSpPr>
         <p:spPr>
           <a:xfrm>
-            <a:off x="13106398" y="4800600"/>
-            <a:ext cx="9525" cy="533400"/>
+            <a:off x="6934200" y="4686300"/>
+            <a:ext cx="1866900" cy="28575"/>
           </a:xfrm>
           <a:prstGeom prst="rect">
             <a:avLst/>
           </a:prstGeom>
           <a:solidFill>
-            <a:srgbClr val="1A2E6E"/>
+            <a:srgbClr val="01FFB7"/>
           </a:solidFill>
           <a:ln>
             <a:noFill/>
@@ -3632,14 +3804,14 @@
       </p:sp>
       <p:sp>
         <p:nvSpPr>
-          <p:cNvPr id="16" name="TextBox 15"/>
+          <p:cNvPr id="21" name="TextBox 20"/>
           <p:cNvSpPr txBox="1"/>
           <p:nvPr/>
         </p:nvSpPr>
         <p:spPr>
           <a:xfrm>
-            <a:off x="13296898" y="4762500"/>
-            <a:ext cx="1866899" cy="381000"/>
+            <a:off x="6934200" y="4267200"/>
+            <a:ext cx="228600" cy="342900"/>
           </a:xfrm>
           <a:prstGeom prst="rect">
             <a:avLst/>
@@ -3647,34 +3819,34 @@
           <a:noFill/>
         </p:spPr>
         <p:txBody>
-          <a:bodyPr wrap="square" lIns="0" tIns="0" rIns="0" bIns="0">
+          <a:bodyPr wrap="none">
             <a:spAutoFit/>
           </a:bodyPr>
           <a:lstStyle/>
           <a:p>
             <a:pPr algn="l"/>
             <a:r>
-              <a:rPr sz="3600" b="1" i="0">
-                <a:solidFill>
-                  <a:srgbClr val="FFFFFF"/>
-                </a:solidFill>
-                <a:latin typeface="Bookman Old Style"/>
+              <a:rPr sz="1600" b="1">
+                <a:solidFill>
+                  <a:srgbClr val="01133D"/>
+                </a:solidFill>
+                <a:latin typeface="Arial"/>
               </a:rPr>
-              <a:t>2,400</a:t>
-            </a:r>
-          </a:p>
-        </p:txBody>
-      </p:sp>
-      <p:sp>
-        <p:nvSpPr>
-          <p:cNvPr id="17" name="TextBox 16"/>
+              <a:t>$</a:t>
+            </a:r>
+          </a:p>
+        </p:txBody>
+      </p:sp>
+      <p:sp>
+        <p:nvSpPr>
+          <p:cNvPr id="22" name="TextBox 21"/>
           <p:cNvSpPr txBox="1"/>
           <p:nvPr/>
         </p:nvSpPr>
         <p:spPr>
           <a:xfrm>
-            <a:off x="13296898" y="5162550"/>
-            <a:ext cx="1866899" cy="209550"/>
+            <a:off x="7181850" y="4171950"/>
+            <a:ext cx="1866900" cy="514350"/>
           </a:xfrm>
           <a:prstGeom prst="rect">
             <a:avLst/>
@@ -3682,43 +3854,78 @@
           <a:noFill/>
         </p:spPr>
         <p:txBody>
-          <a:bodyPr wrap="square" lIns="0" tIns="0" rIns="0" bIns="0">
+          <a:bodyPr wrap="none">
             <a:spAutoFit/>
           </a:bodyPr>
           <a:lstStyle/>
           <a:p>
             <a:pPr algn="l"/>
             <a:r>
-              <a:rPr sz="900" b="1" i="0">
-                <a:solidFill>
-                  <a:srgbClr val="97B9FF"/>
-                </a:solidFill>
-                <a:latin typeface="Calibri"/>
+              <a:rPr sz="4200" b="1">
+                <a:solidFill>
+                  <a:srgbClr val="01133D"/>
+                </a:solidFill>
+                <a:latin typeface="Bookman Old Style"/>
               </a:rPr>
-              <a:t>SQ FT</a:t>
-            </a:r>
-          </a:p>
-        </p:txBody>
-      </p:sp>
-      <p:sp>
-        <p:nvSpPr>
-          <p:cNvPr id="18" name="Rectangle 17"/>
-          <p:cNvSpPr/>
+              <a:t>3,600</a:t>
+            </a:r>
+          </a:p>
+        </p:txBody>
+      </p:sp>
+      <p:sp>
+        <p:nvSpPr>
+          <p:cNvPr id="23" name="TextBox 22"/>
+          <p:cNvSpPr txBox="1"/>
           <p:nvPr/>
         </p:nvSpPr>
         <p:spPr>
           <a:xfrm>
-            <a:off x="15278097" y="4800600"/>
-            <a:ext cx="9525" cy="533400"/>
+            <a:off x="9105900" y="4343400"/>
+            <a:ext cx="1333500" cy="228600"/>
           </a:xfrm>
           <a:prstGeom prst="rect">
             <a:avLst/>
           </a:prstGeom>
-          <a:solidFill>
-            <a:srgbClr val="1A2E6E"/>
-          </a:solidFill>
-          <a:ln>
-            <a:noFill/>
+          <a:noFill/>
+        </p:spPr>
+        <p:txBody>
+          <a:bodyPr wrap="none">
+            <a:spAutoFit/>
+          </a:bodyPr>
+          <a:lstStyle/>
+          <a:p>
+            <a:pPr algn="l"/>
+            <a:r>
+              <a:rPr sz="1000" b="1">
+                <a:solidFill>
+                  <a:srgbClr val="607080"/>
+                </a:solidFill>
+                <a:latin typeface="Arial"/>
+              </a:rPr>
+              <a:t>PER MONTH</a:t>
+            </a:r>
+          </a:p>
+        </p:txBody>
+      </p:sp>
+      <p:sp>
+        <p:nvSpPr>
+          <p:cNvPr id="24" name="Rectangle 23"/>
+          <p:cNvSpPr/>
+          <p:nvPr/>
+        </p:nvSpPr>
+        <p:spPr>
+          <a:xfrm>
+            <a:off x="10648950" y="4248150"/>
+            <a:ext cx="2362200" cy="361950"/>
+          </a:xfrm>
+          <a:prstGeom prst="rect">
+            <a:avLst/>
+          </a:prstGeom>
+          <a:noFill/>
+          <a:ln w="9525">
+            <a:solidFill>
+              <a:srgbClr val="01FFB7"/>
+            </a:solidFill>
           </a:ln>
         </p:spPr>
         <p:style>
@@ -3745,200 +3952,23 @@
       </p:sp>
       <p:sp>
         <p:nvSpPr>
-          <p:cNvPr id="19" name="TextBox 18"/>
-          <p:cNvSpPr txBox="1"/>
-          <p:nvPr/>
-        </p:nvSpPr>
-        <p:spPr>
-          <a:xfrm>
-            <a:off x="15468597" y="4762500"/>
-            <a:ext cx="1866899" cy="381000"/>
-          </a:xfrm>
-          <a:prstGeom prst="rect">
-            <a:avLst/>
-          </a:prstGeom>
-          <a:noFill/>
-        </p:spPr>
-        <p:txBody>
-          <a:bodyPr wrap="square" lIns="0" tIns="0" rIns="0" bIns="0">
-            <a:spAutoFit/>
-          </a:bodyPr>
-          <a:lstStyle/>
-          <a:p>
-            <a:pPr algn="l"/>
-            <a:r>
-              <a:rPr sz="3600" b="1" i="0">
-                <a:solidFill>
-                  <a:srgbClr val="FFFFFF"/>
-                </a:solidFill>
-                <a:latin typeface="Bookman Old Style"/>
-              </a:rPr>
-              <a:t>1931</a:t>
-            </a:r>
-          </a:p>
-        </p:txBody>
-      </p:sp>
-      <p:sp>
-        <p:nvSpPr>
-          <p:cNvPr id="20" name="TextBox 19"/>
-          <p:cNvSpPr txBox="1"/>
-          <p:nvPr/>
-        </p:nvSpPr>
-        <p:spPr>
-          <a:xfrm>
-            <a:off x="15468597" y="5162550"/>
-            <a:ext cx="1866899" cy="209550"/>
-          </a:xfrm>
-          <a:prstGeom prst="rect">
-            <a:avLst/>
-          </a:prstGeom>
-          <a:noFill/>
-        </p:spPr>
-        <p:txBody>
-          <a:bodyPr wrap="square" lIns="0" tIns="0" rIns="0" bIns="0">
-            <a:spAutoFit/>
-          </a:bodyPr>
-          <a:lstStyle/>
-          <a:p>
-            <a:pPr algn="l"/>
-            <a:r>
-              <a:rPr sz="900" b="1" i="0">
-                <a:solidFill>
-                  <a:srgbClr val="97B9FF"/>
-                </a:solidFill>
-                <a:latin typeface="Calibri"/>
-              </a:rPr>
-              <a:t>BUILT</a:t>
-            </a:r>
-          </a:p>
-        </p:txBody>
-      </p:sp>
-      <p:sp>
-        <p:nvSpPr>
-          <p:cNvPr id="21" name="TextBox 20"/>
-          <p:cNvSpPr txBox="1"/>
-          <p:nvPr/>
-        </p:nvSpPr>
-        <p:spPr>
-          <a:xfrm>
-            <a:off x="8953500" y="5867400"/>
-            <a:ext cx="209550" cy="285750"/>
-          </a:xfrm>
-          <a:prstGeom prst="rect">
-            <a:avLst/>
-          </a:prstGeom>
-          <a:noFill/>
-        </p:spPr>
-        <p:txBody>
-          <a:bodyPr wrap="square" lIns="0" tIns="0" rIns="0" bIns="0">
-            <a:spAutoFit/>
-          </a:bodyPr>
-          <a:lstStyle/>
-          <a:p>
-            <a:pPr algn="l"/>
-            <a:r>
-              <a:rPr sz="1400" b="0" i="0">
-                <a:solidFill>
-                  <a:srgbClr val="01FFB7"/>
-                </a:solidFill>
-                <a:latin typeface="Calibri"/>
-              </a:rPr>
-              <a:t>$</a:t>
-            </a:r>
-          </a:p>
-        </p:txBody>
-      </p:sp>
-      <p:sp>
-        <p:nvSpPr>
-          <p:cNvPr id="22" name="TextBox 21"/>
-          <p:cNvSpPr txBox="1"/>
-          <p:nvPr/>
-        </p:nvSpPr>
-        <p:spPr>
-          <a:xfrm>
-            <a:off x="9182100" y="5810250"/>
-            <a:ext cx="1714500" cy="514350"/>
-          </a:xfrm>
-          <a:prstGeom prst="rect">
-            <a:avLst/>
-          </a:prstGeom>
-          <a:noFill/>
-        </p:spPr>
-        <p:txBody>
-          <a:bodyPr wrap="square" lIns="0" tIns="0" rIns="0" bIns="0">
-            <a:spAutoFit/>
-          </a:bodyPr>
-          <a:lstStyle/>
-          <a:p>
-            <a:pPr algn="l"/>
-            <a:r>
-              <a:rPr sz="4400" b="1" i="0">
-                <a:solidFill>
-                  <a:srgbClr val="01FFB7"/>
-                </a:solidFill>
-                <a:latin typeface="Bookman Old Style"/>
-              </a:rPr>
-              <a:t>5,500</a:t>
-            </a:r>
-          </a:p>
-        </p:txBody>
-      </p:sp>
-      <p:sp>
-        <p:nvSpPr>
-          <p:cNvPr id="23" name="TextBox 22"/>
-          <p:cNvSpPr txBox="1"/>
-          <p:nvPr/>
-        </p:nvSpPr>
-        <p:spPr>
-          <a:xfrm>
-            <a:off x="11029950" y="5943600"/>
-            <a:ext cx="1143000" cy="247649"/>
-          </a:xfrm>
-          <a:prstGeom prst="rect">
-            <a:avLst/>
-          </a:prstGeom>
-          <a:noFill/>
-        </p:spPr>
-        <p:txBody>
-          <a:bodyPr wrap="square" lIns="0" tIns="0" rIns="0" bIns="0">
-            <a:spAutoFit/>
-          </a:bodyPr>
-          <a:lstStyle/>
-          <a:p>
-            <a:pPr algn="l"/>
-            <a:r>
-              <a:rPr sz="1000" b="1" i="0">
-                <a:solidFill>
-                  <a:srgbClr val="607090"/>
-                </a:solidFill>
-                <a:latin typeface="Calibri"/>
-              </a:rPr>
-              <a:t>PER MONTH</a:t>
-            </a:r>
-          </a:p>
-        </p:txBody>
-      </p:sp>
-      <p:sp>
-        <p:nvSpPr>
-          <p:cNvPr id="24" name="Rectangle 23"/>
+          <p:cNvPr id="25" name="Oval 24"/>
           <p:cNvSpPr/>
           <p:nvPr/>
         </p:nvSpPr>
         <p:spPr>
           <a:xfrm>
-            <a:off x="12344400" y="5886450"/>
-            <a:ext cx="2571750" cy="342900"/>
-          </a:xfrm>
-          <a:prstGeom prst="rect">
+            <a:off x="10763250" y="4391025"/>
+            <a:ext cx="76200" cy="76200"/>
+          </a:xfrm>
+          <a:prstGeom prst="ellipse">
             <a:avLst/>
           </a:prstGeom>
           <a:solidFill>
-            <a:srgbClr val="091A4A"/>
+            <a:srgbClr val="01FFB7"/>
           </a:solidFill>
-          <a:ln w="9525">
-            <a:solidFill>
-              <a:srgbClr val="018070"/>
-            </a:solidFill>
+          <a:ln>
+            <a:noFill/>
           </a:ln>
         </p:spPr>
         <p:style>
@@ -3965,14 +3995,14 @@
       </p:sp>
       <p:sp>
         <p:nvSpPr>
-          <p:cNvPr id="25" name="TextBox 24"/>
+          <p:cNvPr id="26" name="TextBox 25"/>
           <p:cNvSpPr txBox="1"/>
           <p:nvPr/>
         </p:nvSpPr>
         <p:spPr>
           <a:xfrm>
-            <a:off x="12458700" y="5962650"/>
-            <a:ext cx="2457450" cy="209550"/>
+            <a:off x="10896600" y="4343400"/>
+            <a:ext cx="2038350" cy="190500"/>
           </a:xfrm>
           <a:prstGeom prst="rect">
             <a:avLst/>
@@ -3980,40 +4010,110 @@
           <a:noFill/>
         </p:spPr>
         <p:txBody>
-          <a:bodyPr wrap="square" lIns="0" tIns="0" rIns="0" bIns="0">
+          <a:bodyPr wrap="none">
             <a:spAutoFit/>
           </a:bodyPr>
           <a:lstStyle/>
           <a:p>
             <a:pPr algn="l"/>
             <a:r>
-              <a:rPr sz="1000" b="1" i="0">
-                <a:solidFill>
-                  <a:srgbClr val="01FFB7"/>
-                </a:solidFill>
-                <a:latin typeface="Calibri"/>
+              <a:rPr sz="750" b="1">
+                <a:solidFill>
+                  <a:srgbClr val="01133D"/>
+                </a:solidFill>
+                <a:latin typeface="Arial"/>
               </a:rPr>
-              <a:t>●  Available Aug 1, 2026</a:t>
-            </a:r>
-          </a:p>
-        </p:txBody>
-      </p:sp>
-      <p:sp>
-        <p:nvSpPr>
-          <p:cNvPr id="26" name="Rectangle 25"/>
+              <a:t>AVAILABLE AUG 15, 2026</a:t>
+            </a:r>
+          </a:p>
+        </p:txBody>
+      </p:sp>
+      <p:sp>
+        <p:nvSpPr>
+          <p:cNvPr id="27" name="TextBox 26"/>
+          <p:cNvSpPr txBox="1"/>
+          <p:nvPr/>
+        </p:nvSpPr>
+        <p:spPr>
+          <a:xfrm>
+            <a:off x="6934200" y="4800600"/>
+            <a:ext cx="8001000" cy="171450"/>
+          </a:xfrm>
+          <a:prstGeom prst="rect">
+            <a:avLst/>
+          </a:prstGeom>
+          <a:noFill/>
+        </p:spPr>
+        <p:txBody>
+          <a:bodyPr wrap="none">
+            <a:spAutoFit/>
+          </a:bodyPr>
+          <a:lstStyle/>
+          <a:p>
+            <a:pPr algn="l"/>
+            <a:r>
+              <a:rPr sz="800" b="1">
+                <a:solidFill>
+                  <a:srgbClr val="4C4DC3"/>
+                </a:solidFill>
+                <a:latin typeface="Arial"/>
+              </a:rPr>
+              <a:t>ABOUT THIS HOME</a:t>
+            </a:r>
+          </a:p>
+        </p:txBody>
+      </p:sp>
+      <p:sp>
+        <p:nvSpPr>
+          <p:cNvPr id="28" name="TextBox 27"/>
+          <p:cNvSpPr txBox="1"/>
+          <p:nvPr/>
+        </p:nvSpPr>
+        <p:spPr>
+          <a:xfrm>
+            <a:off x="6934200" y="5010150"/>
+            <a:ext cx="8001000" cy="571500"/>
+          </a:xfrm>
+          <a:prstGeom prst="rect">
+            <a:avLst/>
+          </a:prstGeom>
+          <a:noFill/>
+        </p:spPr>
+        <p:txBody>
+          <a:bodyPr wrap="square">
+            <a:spAutoFit/>
+          </a:bodyPr>
+          <a:lstStyle/>
+          <a:p>
+            <a:pPr algn="l"/>
+            <a:r>
+              <a:rPr sz="950" b="0">
+                <a:solidFill>
+                  <a:srgbClr val="01133D"/>
+                </a:solidFill>
+                <a:latin typeface="Arial"/>
+              </a:rPr>
+              <a:t>Stunning waterfront residence with panoramic Hudson River views. Renovated kitchen, spa-inspired baths, in-unit laundry, central air, and a private outdoor terrace. Steps from the Grove Street PATH station.</a:t>
+            </a:r>
+          </a:p>
+        </p:txBody>
+      </p:sp>
+      <p:sp>
+        <p:nvSpPr>
+          <p:cNvPr id="29" name="Rectangle 28"/>
           <p:cNvSpPr/>
           <p:nvPr/>
         </p:nvSpPr>
         <p:spPr>
           <a:xfrm>
-            <a:off x="8953500" y="6648450"/>
-            <a:ext cx="8953500" cy="9525"/>
+            <a:off x="6477000" y="8572500"/>
+            <a:ext cx="11811000" cy="1714500"/>
           </a:xfrm>
           <a:prstGeom prst="rect">
             <a:avLst/>
           </a:prstGeom>
           <a:solidFill>
-            <a:srgbClr val="1A2E6E"/>
+            <a:srgbClr val="01133D"/>
           </a:solidFill>
           <a:ln>
             <a:noFill/>
@@ -4043,14 +4143,57 @@
       </p:sp>
       <p:sp>
         <p:nvSpPr>
-          <p:cNvPr id="27" name="TextBox 26"/>
+          <p:cNvPr id="30" name="Rectangle 29"/>
+          <p:cNvSpPr/>
+          <p:nvPr/>
+        </p:nvSpPr>
+        <p:spPr>
+          <a:xfrm>
+            <a:off x="6477000" y="8572500"/>
+            <a:ext cx="11811000" cy="19050"/>
+          </a:xfrm>
+          <a:prstGeom prst="rect">
+            <a:avLst/>
+          </a:prstGeom>
+          <a:solidFill>
+            <a:srgbClr val="01FFB7"/>
+          </a:solidFill>
+          <a:ln>
+            <a:noFill/>
+          </a:ln>
+        </p:spPr>
+        <p:style>
+          <a:lnRef idx="1">
+            <a:schemeClr val="accent1"/>
+          </a:lnRef>
+          <a:fillRef idx="3">
+            <a:schemeClr val="accent1"/>
+          </a:fillRef>
+          <a:effectRef idx="2">
+            <a:schemeClr val="accent1"/>
+          </a:effectRef>
+          <a:fontRef idx="minor">
+            <a:schemeClr val="lt1"/>
+          </a:fontRef>
+        </p:style>
+        <p:txBody>
+          <a:bodyPr rtlCol="0" anchor="ctr"/>
+          <a:lstStyle/>
+          <a:p>
+            <a:pPr algn="ctr"/>
+          </a:p>
+        </p:txBody>
+      </p:sp>
+      <p:sp>
+        <p:nvSpPr>
+          <p:cNvPr id="31" name="TextBox 30"/>
           <p:cNvSpPr txBox="1"/>
           <p:nvPr/>
         </p:nvSpPr>
         <p:spPr>
           <a:xfrm>
-            <a:off x="8953500" y="6781800"/>
-            <a:ext cx="2571750" cy="171450"/>
+            <a:off x="6934200" y="8763000"/>
+            <a:ext cx="1905000" cy="171450"/>
           </a:xfrm>
           <a:prstGeom prst="rect">
             <a:avLst/>
@@ -4058,18 +4201,18 @@
           <a:noFill/>
         </p:spPr>
         <p:txBody>
-          <a:bodyPr wrap="square" lIns="0" tIns="0" rIns="0" bIns="0">
+          <a:bodyPr wrap="none">
             <a:spAutoFit/>
           </a:bodyPr>
           <a:lstStyle/>
           <a:p>
             <a:pPr algn="l"/>
             <a:r>
-              <a:rPr sz="800" b="1" i="0">
+              <a:rPr sz="700" b="1">
                 <a:solidFill>
                   <a:srgbClr val="97B9FF"/>
                 </a:solidFill>
-                <a:latin typeface="Calibri"/>
+                <a:latin typeface="Arial"/>
               </a:rPr>
               <a:t>LEASING CONTACT</a:t>
             </a:r>
@@ -4078,14 +4221,14 @@
       </p:sp>
       <p:sp>
         <p:nvSpPr>
-          <p:cNvPr id="28" name="TextBox 27"/>
+          <p:cNvPr id="32" name="TextBox 31"/>
           <p:cNvSpPr txBox="1"/>
           <p:nvPr/>
         </p:nvSpPr>
         <p:spPr>
           <a:xfrm>
-            <a:off x="8953500" y="6972300"/>
-            <a:ext cx="2571750" cy="323850"/>
+            <a:off x="6934200" y="8972550"/>
+            <a:ext cx="2476500" cy="304800"/>
           </a:xfrm>
           <a:prstGeom prst="rect">
             <a:avLst/>
@@ -4093,34 +4236,34 @@
           <a:noFill/>
         </p:spPr>
         <p:txBody>
-          <a:bodyPr wrap="square" lIns="0" tIns="0" rIns="0" bIns="0">
+          <a:bodyPr wrap="none">
             <a:spAutoFit/>
           </a:bodyPr>
           <a:lstStyle/>
           <a:p>
             <a:pPr algn="l"/>
             <a:r>
-              <a:rPr sz="2200" b="1" i="0">
+              <a:rPr sz="2000" b="0">
                 <a:solidFill>
                   <a:srgbClr val="FFFFFF"/>
                 </a:solidFill>
                 <a:latin typeface="Bookman Old Style"/>
               </a:rPr>
-              <a:t>Sarah Levy</a:t>
-            </a:r>
-          </a:p>
-        </p:txBody>
-      </p:sp>
-      <p:sp>
-        <p:nvSpPr>
-          <p:cNvPr id="29" name="TextBox 28"/>
+              <a:t>Marcus Levy</a:t>
+            </a:r>
+          </a:p>
+        </p:txBody>
+      </p:sp>
+      <p:sp>
+        <p:nvSpPr>
+          <p:cNvPr id="33" name="TextBox 32"/>
           <p:cNvSpPr txBox="1"/>
           <p:nvPr/>
         </p:nvSpPr>
         <p:spPr>
           <a:xfrm>
-            <a:off x="11715750" y="6781800"/>
-            <a:ext cx="1714500" cy="171450"/>
+            <a:off x="9601200" y="8763000"/>
+            <a:ext cx="1524000" cy="171450"/>
           </a:xfrm>
           <a:prstGeom prst="rect">
             <a:avLst/>
@@ -4128,18 +4271,18 @@
           <a:noFill/>
         </p:spPr>
         <p:txBody>
-          <a:bodyPr wrap="square" lIns="0" tIns="0" rIns="0" bIns="0">
+          <a:bodyPr wrap="none">
             <a:spAutoFit/>
           </a:bodyPr>
           <a:lstStyle/>
           <a:p>
             <a:pPr algn="l"/>
             <a:r>
-              <a:rPr sz="800" b="1" i="0">
+              <a:rPr sz="700" b="1">
                 <a:solidFill>
                   <a:srgbClr val="97B9FF"/>
                 </a:solidFill>
-                <a:latin typeface="Calibri"/>
+                <a:latin typeface="Arial"/>
               </a:rPr>
               <a:t>PHONE</a:t>
             </a:r>
@@ -4148,14 +4291,14 @@
       </p:sp>
       <p:sp>
         <p:nvSpPr>
-          <p:cNvPr id="30" name="TextBox 29"/>
+          <p:cNvPr id="34" name="TextBox 33"/>
           <p:cNvSpPr txBox="1"/>
           <p:nvPr/>
         </p:nvSpPr>
         <p:spPr>
           <a:xfrm>
-            <a:off x="11715750" y="6972300"/>
-            <a:ext cx="1809750" cy="266700"/>
+            <a:off x="9601200" y="8972550"/>
+            <a:ext cx="1905000" cy="247650"/>
           </a:xfrm>
           <a:prstGeom prst="rect">
             <a:avLst/>
@@ -4163,34 +4306,34 @@
           <a:noFill/>
         </p:spPr>
         <p:txBody>
-          <a:bodyPr wrap="square" lIns="0" tIns="0" rIns="0" bIns="0">
+          <a:bodyPr wrap="none">
             <a:spAutoFit/>
           </a:bodyPr>
           <a:lstStyle/>
           <a:p>
             <a:pPr algn="l"/>
             <a:r>
-              <a:rPr sz="1400" b="0" i="0">
+              <a:rPr sz="1300" b="0">
                 <a:solidFill>
                   <a:srgbClr val="FFFFFF"/>
                 </a:solidFill>
-                <a:latin typeface="Calibri"/>
+                <a:latin typeface="Arial"/>
               </a:rPr>
-              <a:t>(212) 555-0148</a:t>
-            </a:r>
-          </a:p>
-        </p:txBody>
-      </p:sp>
-      <p:sp>
-        <p:nvSpPr>
-          <p:cNvPr id="31" name="TextBox 30"/>
+              <a:t>(212) 555-0291</a:t>
+            </a:r>
+          </a:p>
+        </p:txBody>
+      </p:sp>
+      <p:sp>
+        <p:nvSpPr>
+          <p:cNvPr id="35" name="TextBox 34"/>
           <p:cNvSpPr txBox="1"/>
           <p:nvPr/>
         </p:nvSpPr>
         <p:spPr>
           <a:xfrm>
-            <a:off x="13639800" y="6781800"/>
-            <a:ext cx="3429000" cy="171450"/>
+            <a:off x="11601450" y="8763000"/>
+            <a:ext cx="1714500" cy="171450"/>
           </a:xfrm>
           <a:prstGeom prst="rect">
             <a:avLst/>
@@ -4198,18 +4341,18 @@
           <a:noFill/>
         </p:spPr>
         <p:txBody>
-          <a:bodyPr wrap="square" lIns="0" tIns="0" rIns="0" bIns="0">
+          <a:bodyPr wrap="none">
             <a:spAutoFit/>
           </a:bodyPr>
           <a:lstStyle/>
           <a:p>
             <a:pPr algn="l"/>
             <a:r>
-              <a:rPr sz="800" b="1" i="0">
+              <a:rPr sz="700" b="1">
                 <a:solidFill>
                   <a:srgbClr val="97B9FF"/>
                 </a:solidFill>
-                <a:latin typeface="Calibri"/>
+                <a:latin typeface="Arial"/>
               </a:rPr>
               <a:t>EMAIL</a:t>
             </a:r>
@@ -4218,14 +4361,14 @@
       </p:sp>
       <p:sp>
         <p:nvSpPr>
-          <p:cNvPr id="32" name="TextBox 31"/>
+          <p:cNvPr id="36" name="TextBox 35"/>
           <p:cNvSpPr txBox="1"/>
           <p:nvPr/>
         </p:nvSpPr>
         <p:spPr>
           <a:xfrm>
-            <a:off x="13639800" y="6972300"/>
-            <a:ext cx="3619500" cy="266700"/>
+            <a:off x="11601450" y="8972550"/>
+            <a:ext cx="4000500" cy="247650"/>
           </a:xfrm>
           <a:prstGeom prst="rect">
             <a:avLst/>
@@ -4233,18 +4376,18 @@
           <a:noFill/>
         </p:spPr>
         <p:txBody>
-          <a:bodyPr wrap="square" lIns="0" tIns="0" rIns="0" bIns="0">
+          <a:bodyPr wrap="none">
             <a:spAutoFit/>
           </a:bodyPr>
           <a:lstStyle/>
           <a:p>
             <a:pPr algn="l"/>
             <a:r>
-              <a:rPr sz="1300" b="0" i="0">
+              <a:rPr sz="1300" b="0">
                 <a:solidFill>
                   <a:srgbClr val="FFFFFF"/>
                 </a:solidFill>
-                <a:latin typeface="Calibri"/>
+                <a:latin typeface="Arial"/>
               </a:rPr>
               <a:t>leasing@levylegacygroup.com</a:t>
             </a:r>
@@ -4253,14 +4396,14 @@
       </p:sp>
       <p:sp>
         <p:nvSpPr>
-          <p:cNvPr id="33" name="TextBox 32"/>
+          <p:cNvPr id="37" name="TextBox 36"/>
           <p:cNvSpPr txBox="1"/>
           <p:nvPr/>
         </p:nvSpPr>
         <p:spPr>
           <a:xfrm>
-            <a:off x="8953500" y="9944100"/>
-            <a:ext cx="8953500" cy="266700"/>
+            <a:off x="6934200" y="9886950"/>
+            <a:ext cx="7620000" cy="171450"/>
           </a:xfrm>
           <a:prstGeom prst="rect">
             <a:avLst/>
@@ -4268,20 +4411,20 @@
           <a:noFill/>
         </p:spPr>
         <p:txBody>
-          <a:bodyPr wrap="square" lIns="0" tIns="0" rIns="0" bIns="0">
+          <a:bodyPr wrap="none">
             <a:spAutoFit/>
           </a:bodyPr>
           <a:lstStyle/>
           <a:p>
             <a:pPr algn="l"/>
             <a:r>
-              <a:rPr sz="800" b="0" i="0">
-                <a:solidFill>
-                  <a:srgbClr val="3A4870"/>
-                </a:solidFill>
-                <a:latin typeface="Calibri"/>
+              <a:rPr sz="650" b="0">
+                <a:solidFill>
+                  <a:srgbClr val="607090"/>
+                </a:solidFill>
+                <a:latin typeface="Arial"/>
               </a:rPr>
-              <a:t>Equal Housing Opportunity  ·  Licensed Real Estate Broker  ·  New York State</a:t>
+              <a:t>Equal Housing Opportunity  ·  Licensed Real Estate Broker  ·  New Jersey</a:t>
             </a:r>
           </a:p>
         </p:txBody>

</xml_diff>